<commit_message>
updated lesson 7 slides
</commit_message>
<xml_diff>
--- a/docs/assets/slides/OutbackRobots_Lesson7_Slides_AIandLLMs.pptx
+++ b/docs/assets/slides/OutbackRobots_Lesson7_Slides_AIandLLMs.pptx
@@ -5,7 +5,7 @@
     <p:sldMasterId id="2147483648" r:id="rId1"/>
   </p:sldMasterIdLst>
   <p:notesMasterIdLst>
-    <p:notesMasterId r:id="rId25"/>
+    <p:notesMasterId r:id="rId26"/>
   </p:notesMasterIdLst>
   <p:sldIdLst>
     <p:sldId id="370" r:id="rId2"/>
@@ -29,20 +29,21 @@
     <p:sldId id="386" r:id="rId20"/>
     <p:sldId id="387" r:id="rId21"/>
     <p:sldId id="388" r:id="rId22"/>
-    <p:sldId id="371" r:id="rId23"/>
-    <p:sldId id="355" r:id="rId24"/>
+    <p:sldId id="394" r:id="rId23"/>
+    <p:sldId id="393" r:id="rId24"/>
+    <p:sldId id="355" r:id="rId25"/>
   </p:sldIdLst>
   <p:sldSz cx="9906000" cy="6858000" type="A4"/>
   <p:notesSz cx="7099300" cy="10234613"/>
   <p:embeddedFontLst>
     <p:embeddedFont>
       <p:font typeface="Berlin Sans FB" panose="020E0602020502020306" pitchFamily="34" charset="0"/>
-      <p:regular r:id="rId26"/>
-      <p:bold r:id="rId27"/>
+      <p:regular r:id="rId27"/>
+      <p:bold r:id="rId28"/>
     </p:embeddedFont>
     <p:embeddedFont>
       <p:font typeface="Berlin Sans FB Demi" panose="020E0802020502020306" pitchFamily="34" charset="0"/>
-      <p:bold r:id="rId28"/>
+      <p:bold r:id="rId29"/>
     </p:embeddedFont>
   </p:embeddedFontLst>
   <p:defaultTextStyle>
@@ -170,11 +171,12 @@
             <p14:sldId id="386"/>
             <p14:sldId id="387"/>
             <p14:sldId id="388"/>
+            <p14:sldId id="394"/>
           </p14:sldIdLst>
         </p14:section>
         <p14:section name="Wrap Up" id="{85C9C7DE-C9E5-404F-B6C1-4A2C78765023}">
           <p14:sldIdLst>
-            <p14:sldId id="371"/>
+            <p14:sldId id="393"/>
             <p14:sldId id="355"/>
           </p14:sldIdLst>
         </p14:section>
@@ -208,9 +210,37 @@
 <file path=ppt/revisionInfo.xml><?xml version="1.0" encoding="utf-8"?>
 <p1510:revInfo xmlns:a="http://schemas.openxmlformats.org/drawingml/2006/main" xmlns:r="http://schemas.openxmlformats.org/officeDocument/2006/relationships" xmlns:p1510="http://schemas.microsoft.com/office/powerpoint/2015/10/main">
   <p1510:revLst>
-    <p1510:client id="{E24FDDFF-D4AB-4161-A23B-EBA4D9EED9F9}" v="12" dt="2026-03-10T00:29:42.039"/>
+    <p1510:client id="{93130B51-71EC-49DE-BFA9-C504DC508C9E}" v="2" dt="2026-06-22T08:37:00.410"/>
   </p1510:revLst>
 </p1510:revInfo>
+</file>
+
+<file path=ppt/changesInfos/changesInfo1.xml><?xml version="1.0" encoding="utf-8"?>
+<pc:chgInfo xmlns:a="http://schemas.openxmlformats.org/drawingml/2006/main" xmlns:r="http://schemas.openxmlformats.org/officeDocument/2006/relationships" xmlns:ac="http://schemas.microsoft.com/office/drawing/2013/main/command" xmlns:pc="http://schemas.microsoft.com/office/powerpoint/2013/main/command">
+  <pc:docChgLst>
+    <pc:chgData name="Ben Kelly" userId="79179b44-934c-4bdd-82f6-75b69b2eecee" providerId="ADAL" clId="{93130B51-71EC-49DE-BFA9-C504DC508C9E}"/>
+    <pc:docChg chg="addSld modSld sldOrd">
+      <pc:chgData name="Ben Kelly" userId="79179b44-934c-4bdd-82f6-75b69b2eecee" providerId="ADAL" clId="{93130B51-71EC-49DE-BFA9-C504DC508C9E}" dt="2026-06-22T08:37:00.407" v="2"/>
+      <pc:docMkLst>
+        <pc:docMk/>
+      </pc:docMkLst>
+      <pc:sldChg chg="add ord">
+        <pc:chgData name="Ben Kelly" userId="79179b44-934c-4bdd-82f6-75b69b2eecee" providerId="ADAL" clId="{93130B51-71EC-49DE-BFA9-C504DC508C9E}" dt="2026-06-22T08:36:36.929" v="1"/>
+        <pc:sldMkLst>
+          <pc:docMk/>
+          <pc:sldMk cId="879600154" sldId="393"/>
+        </pc:sldMkLst>
+      </pc:sldChg>
+      <pc:sldChg chg="add">
+        <pc:chgData name="Ben Kelly" userId="79179b44-934c-4bdd-82f6-75b69b2eecee" providerId="ADAL" clId="{93130B51-71EC-49DE-BFA9-C504DC508C9E}" dt="2026-06-22T08:37:00.407" v="2"/>
+        <pc:sldMkLst>
+          <pc:docMk/>
+          <pc:sldMk cId="1527236185" sldId="394"/>
+        </pc:sldMkLst>
+      </pc:sldChg>
+    </pc:docChg>
+  </pc:docChgLst>
+</pc:chgInfo>
 </file>
 
 <file path=ppt/notesMasters/notesMaster1.xml><?xml version="1.0" encoding="utf-8"?>
@@ -295,7 +325,7 @@
           <a:p>
             <a:fld id="{4F3F5AEF-4F6C-41E2-869B-89F90C9BC9CB}" type="datetimeFigureOut">
               <a:rPr lang="en-US" smtClean="0"/>
-              <a:t>3/13/2026</a:t>
+              <a:t>6/22/2026</a:t>
             </a:fld>
             <a:endParaRPr lang="en-US"/>
           </a:p>
@@ -741,7 +771,7 @@
           <a:p>
             <a:fld id="{0C641F1D-C242-463A-9118-CEC8A32732E1}" type="datetime1">
               <a:rPr lang="en-US" smtClean="0"/>
-              <a:t>3/13/2026</a:t>
+              <a:t>6/22/2026</a:t>
             </a:fld>
             <a:endParaRPr lang="en-US"/>
           </a:p>
@@ -1864,7 +1894,7 @@
           <a:p>
             <a:fld id="{6C3E4B74-615C-44D1-8875-0F95FDB4ACF1}" type="datetime1">
               <a:rPr lang="en-US" smtClean="0"/>
-              <a:t>3/13/2026</a:t>
+              <a:t>6/22/2026</a:t>
             </a:fld>
             <a:endParaRPr lang="en-US"/>
           </a:p>
@@ -2112,7 +2142,7 @@
           <a:p>
             <a:fld id="{ED101441-3954-4234-8E77-79F8676957CB}" type="datetime1">
               <a:rPr lang="en-US" smtClean="0"/>
-              <a:t>3/13/2026</a:t>
+              <a:t>6/22/2026</a:t>
             </a:fld>
             <a:endParaRPr lang="en-US"/>
           </a:p>
@@ -2276,7 +2306,7 @@
           <a:p>
             <a:fld id="{FE5290FD-71D0-407D-83AB-396A7FD0C9D0}" type="datetime1">
               <a:rPr lang="en-US" smtClean="0"/>
-              <a:t>3/13/2026</a:t>
+              <a:t>6/22/2026</a:t>
             </a:fld>
             <a:endParaRPr lang="en-US"/>
           </a:p>
@@ -2450,7 +2480,7 @@
           <a:p>
             <a:fld id="{C1019B73-AB8A-401C-A09D-1C931BCE90B8}" type="datetime1">
               <a:rPr lang="en-US" smtClean="0"/>
-              <a:t>3/13/2026</a:t>
+              <a:t>6/22/2026</a:t>
             </a:fld>
             <a:endParaRPr lang="en-US"/>
           </a:p>
@@ -2614,7 +2644,7 @@
           <a:p>
             <a:fld id="{D1C8F71B-FE01-41BB-BA09-F81DE1617D4D}" type="datetime1">
               <a:rPr lang="en-US" smtClean="0"/>
-              <a:t>3/13/2026</a:t>
+              <a:t>6/22/2026</a:t>
             </a:fld>
             <a:endParaRPr lang="en-US"/>
           </a:p>
@@ -2855,7 +2885,7 @@
           <a:p>
             <a:fld id="{3C1A2404-A312-4657-8292-B0E4B798C0E7}" type="datetime1">
               <a:rPr lang="en-US" smtClean="0"/>
-              <a:t>3/13/2026</a:t>
+              <a:t>6/22/2026</a:t>
             </a:fld>
             <a:endParaRPr lang="en-US"/>
           </a:p>
@@ -3136,7 +3166,7 @@
           <a:p>
             <a:fld id="{A9944A73-44BC-44C3-B99F-A0232951B267}" type="datetime1">
               <a:rPr lang="en-US" smtClean="0"/>
-              <a:t>3/13/2026</a:t>
+              <a:t>6/22/2026</a:t>
             </a:fld>
             <a:endParaRPr lang="en-US"/>
           </a:p>
@@ -3551,7 +3581,7 @@
           <a:p>
             <a:fld id="{FED12FDD-77D0-4A09-A7BF-76E5C63CBF2F}" type="datetime1">
               <a:rPr lang="en-US" smtClean="0"/>
-              <a:t>3/13/2026</a:t>
+              <a:t>6/22/2026</a:t>
             </a:fld>
             <a:endParaRPr lang="en-US"/>
           </a:p>
@@ -3664,7 +3694,7 @@
           <a:p>
             <a:fld id="{1BE876FE-512A-4774-A2B9-2BDC34E4BD18}" type="datetime1">
               <a:rPr lang="en-US" smtClean="0"/>
-              <a:t>3/13/2026</a:t>
+              <a:t>6/22/2026</a:t>
             </a:fld>
             <a:endParaRPr lang="en-US"/>
           </a:p>
@@ -4974,7 +5004,7 @@
           <a:p>
             <a:fld id="{8BF02AB2-EABE-44C0-9D58-D80514717591}" type="datetime1">
               <a:rPr lang="en-US" smtClean="0"/>
-              <a:t>3/13/2026</a:t>
+              <a:t>6/22/2026</a:t>
             </a:fld>
             <a:endParaRPr lang="en-US"/>
           </a:p>
@@ -7600,7 +7630,7 @@
           <p:cNvPr id="2" name="Slide Number Placeholder 1">
             <a:extLst>
               <a:ext uri="{FF2B5EF4-FFF2-40B4-BE49-F238E27FC236}">
-                <a16:creationId xmlns:a16="http://schemas.microsoft.com/office/drawing/2014/main" id="{FF3B77EB-5A54-0C07-2406-B303EA637F14}"/>
+                <a16:creationId xmlns:a16="http://schemas.microsoft.com/office/drawing/2014/main" id="{ACD8E7D9-6C25-6C06-6A41-89892B2B2D7C}"/>
               </a:ext>
             </a:extLst>
           </p:cNvPr>
@@ -7630,7 +7660,7 @@
           <p:cNvPr id="3" name="Text Placeholder 2">
             <a:extLst>
               <a:ext uri="{FF2B5EF4-FFF2-40B4-BE49-F238E27FC236}">
-                <a16:creationId xmlns:a16="http://schemas.microsoft.com/office/drawing/2014/main" id="{FAEE4E71-5876-A2C4-FD26-CE548216836A}"/>
+                <a16:creationId xmlns:a16="http://schemas.microsoft.com/office/drawing/2014/main" id="{26FBF710-CF7F-7F50-8D0A-4854AADBCDF6}"/>
               </a:ext>
             </a:extLst>
           </p:cNvPr>
@@ -7648,7 +7678,7 @@
           <a:p>
             <a:r>
               <a:rPr lang="en-AU" dirty="0"/>
-              <a:t>Questionnaire</a:t>
+              <a:t>Blossom’s Sensor</a:t>
             </a:r>
           </a:p>
         </p:txBody>
@@ -7658,7 +7688,7 @@
           <p:cNvPr id="4" name="Text Placeholder 3">
             <a:extLst>
               <a:ext uri="{FF2B5EF4-FFF2-40B4-BE49-F238E27FC236}">
-                <a16:creationId xmlns:a16="http://schemas.microsoft.com/office/drawing/2014/main" id="{E13AA2F1-3E8E-F220-694A-21D127C46EFF}"/>
+                <a16:creationId xmlns:a16="http://schemas.microsoft.com/office/drawing/2014/main" id="{62ABC290-95D3-3450-B7D9-FE60FF4BF806}"/>
               </a:ext>
             </a:extLst>
           </p:cNvPr>
@@ -7669,10 +7699,79 @@
             <p:ph type="body" sz="quarter" idx="14"/>
           </p:nvPr>
         </p:nvSpPr>
-        <p:spPr/>
-        <p:txBody>
-          <a:bodyPr/>
-          <a:lstStyle/>
+        <p:spPr>
+          <a:xfrm>
+            <a:off x="489396" y="1501736"/>
+            <a:ext cx="8254554" cy="3562350"/>
+          </a:xfrm>
+        </p:spPr>
+        <p:txBody>
+          <a:bodyPr/>
+          <a:lstStyle/>
+          <a:p>
+            <a:r>
+              <a:rPr lang="en-AU" dirty="0"/>
+              <a:t>It’s time to plug in Blossom’s sensor, it will fit into the top hat which can be tied to Blossom’s head</a:t>
+            </a:r>
+          </a:p>
+          <a:p>
+            <a:r>
+              <a:rPr lang="en-AU" dirty="0"/>
+              <a:t>Plug in the wires, RED to VCC/POWER, BLACK to GND, BROWN to TRIG, BLUE to ECHO</a:t>
+            </a:r>
+          </a:p>
+          <a:p>
+            <a:r>
+              <a:rPr lang="en-AU" dirty="0"/>
+              <a:t>Plug the Blossom computer into a power source</a:t>
+            </a:r>
+          </a:p>
+          <a:p>
+            <a:r>
+              <a:rPr lang="en-AU" dirty="0"/>
+              <a:t>Wait for the wi-fi to show up and connect</a:t>
+            </a:r>
+          </a:p>
+          <a:p>
+            <a:r>
+              <a:rPr lang="en-AU" dirty="0"/>
+              <a:t>Head to </a:t>
+            </a:r>
+            <a:r>
+              <a:rPr lang="en-US" sz="1800" u="sng" dirty="0">
+                <a:solidFill>
+                  <a:srgbClr val="0000FF"/>
+                </a:solidFill>
+                <a:effectLst/>
+                <a:latin typeface="Calibri" panose="020F0502020204030204" pitchFamily="34" charset="0"/>
+                <a:ea typeface="Calibri" panose="020F0502020204030204" pitchFamily="34" charset="0"/>
+                <a:cs typeface="Arial" panose="020B0604020202020204" pitchFamily="34" charset="0"/>
+                <a:hlinkClick r:id="rId2"/>
+              </a:rPr>
+              <a:t>https://192.168.90.1:8080</a:t>
+            </a:r>
+            <a:r>
+              <a:rPr lang="en-US" sz="1800" dirty="0">
+                <a:effectLst/>
+                <a:latin typeface="Calibri" panose="020F0502020204030204" pitchFamily="34" charset="0"/>
+                <a:ea typeface="Calibri" panose="020F0502020204030204" pitchFamily="34" charset="0"/>
+                <a:cs typeface="Arial" panose="020B0604020202020204" pitchFamily="34" charset="0"/>
+              </a:rPr>
+              <a:t> </a:t>
+            </a:r>
+          </a:p>
+          <a:p>
+            <a:r>
+              <a:rPr lang="en-AU" dirty="0"/>
+              <a:t>Go to Sensor</a:t>
+            </a:r>
+          </a:p>
+          <a:p>
+            <a:r>
+              <a:rPr lang="en-AU" dirty="0"/>
+              <a:t>Can you figure out what Blossom might be coded to do as the sensor value changes?</a:t>
+            </a:r>
+          </a:p>
           <a:p>
             <a:endParaRPr lang="en-AU" dirty="0"/>
           </a:p>
@@ -7681,7 +7780,7 @@
     </p:spTree>
     <p:extLst>
       <p:ext uri="{BB962C8B-B14F-4D97-AF65-F5344CB8AC3E}">
-        <p14:creationId xmlns:p14="http://schemas.microsoft.com/office/powerpoint/2010/main" val="923499938"/>
+        <p14:creationId xmlns:p14="http://schemas.microsoft.com/office/powerpoint/2010/main" val="1527236185"/>
       </p:ext>
     </p:extLst>
   </p:cSld>
@@ -7713,7 +7812,7 @@
           <p:cNvPr id="2" name="Slide Number Placeholder 1">
             <a:extLst>
               <a:ext uri="{FF2B5EF4-FFF2-40B4-BE49-F238E27FC236}">
-                <a16:creationId xmlns:a16="http://schemas.microsoft.com/office/drawing/2014/main" id="{159CE9FC-1BAC-3AC6-42B3-0FDE54699F51}"/>
+                <a16:creationId xmlns:a16="http://schemas.microsoft.com/office/drawing/2014/main" id="{FF3B77EB-5A54-0C07-2406-B303EA637F14}"/>
               </a:ext>
             </a:extLst>
           </p:cNvPr>
@@ -7733,6 +7832,149 @@
               <a:rPr lang="en-US" smtClean="0"/>
               <a:pPr/>
               <a:t>23</a:t>
+            </a:fld>
+            <a:endParaRPr lang="en-US"/>
+          </a:p>
+        </p:txBody>
+      </p:sp>
+      <p:sp>
+        <p:nvSpPr>
+          <p:cNvPr id="3" name="Text Placeholder 2">
+            <a:extLst>
+              <a:ext uri="{FF2B5EF4-FFF2-40B4-BE49-F238E27FC236}">
+                <a16:creationId xmlns:a16="http://schemas.microsoft.com/office/drawing/2014/main" id="{FAEE4E71-5876-A2C4-FD26-CE548216836A}"/>
+              </a:ext>
+            </a:extLst>
+          </p:cNvPr>
+          <p:cNvSpPr>
+            <a:spLocks noGrp="1"/>
+          </p:cNvSpPr>
+          <p:nvPr>
+            <p:ph type="body" sz="quarter" idx="13"/>
+          </p:nvPr>
+        </p:nvSpPr>
+        <p:spPr/>
+        <p:txBody>
+          <a:bodyPr/>
+          <a:lstStyle/>
+          <a:p>
+            <a:r>
+              <a:rPr lang="en-AU" dirty="0"/>
+              <a:t>Survey</a:t>
+            </a:r>
+          </a:p>
+        </p:txBody>
+      </p:sp>
+      <p:sp>
+        <p:nvSpPr>
+          <p:cNvPr id="4" name="Text Placeholder 3">
+            <a:extLst>
+              <a:ext uri="{FF2B5EF4-FFF2-40B4-BE49-F238E27FC236}">
+                <a16:creationId xmlns:a16="http://schemas.microsoft.com/office/drawing/2014/main" id="{E13AA2F1-3E8E-F220-694A-21D127C46EFF}"/>
+              </a:ext>
+            </a:extLst>
+          </p:cNvPr>
+          <p:cNvSpPr>
+            <a:spLocks noGrp="1"/>
+          </p:cNvSpPr>
+          <p:nvPr>
+            <p:ph type="body" sz="quarter" idx="14"/>
+          </p:nvPr>
+        </p:nvSpPr>
+        <p:spPr/>
+        <p:txBody>
+          <a:bodyPr/>
+          <a:lstStyle/>
+          <a:p>
+            <a:endParaRPr lang="en-AU"/>
+          </a:p>
+        </p:txBody>
+      </p:sp>
+      <p:pic>
+        <p:nvPicPr>
+          <p:cNvPr id="6" name="Picture 5">
+            <a:extLst>
+              <a:ext uri="{FF2B5EF4-FFF2-40B4-BE49-F238E27FC236}">
+                <a16:creationId xmlns:a16="http://schemas.microsoft.com/office/drawing/2014/main" id="{7F24838B-E97C-997A-9E7A-D9D94BAE99B1}"/>
+              </a:ext>
+            </a:extLst>
+          </p:cNvPr>
+          <p:cNvPicPr>
+            <a:picLocks noChangeAspect="1"/>
+          </p:cNvPicPr>
+          <p:nvPr/>
+        </p:nvPicPr>
+        <p:blipFill>
+          <a:blip r:embed="rId2"/>
+          <a:stretch>
+            <a:fillRect/>
+          </a:stretch>
+        </p:blipFill>
+        <p:spPr>
+          <a:xfrm>
+            <a:off x="2290834" y="1659810"/>
+            <a:ext cx="5324331" cy="4648954"/>
+          </a:xfrm>
+          <a:prstGeom prst="rect">
+            <a:avLst/>
+          </a:prstGeom>
+        </p:spPr>
+      </p:pic>
+    </p:spTree>
+    <p:extLst>
+      <p:ext uri="{BB962C8B-B14F-4D97-AF65-F5344CB8AC3E}">
+        <p14:creationId xmlns:p14="http://schemas.microsoft.com/office/powerpoint/2010/main" val="879600154"/>
+      </p:ext>
+    </p:extLst>
+  </p:cSld>
+  <p:clrMapOvr>
+    <a:masterClrMapping/>
+  </p:clrMapOvr>
+</p:sld>
+</file>
+
+<file path=ppt/slides/slide24.xml><?xml version="1.0" encoding="utf-8"?>
+<p:sld xmlns:a="http://schemas.openxmlformats.org/drawingml/2006/main" xmlns:r="http://schemas.openxmlformats.org/officeDocument/2006/relationships" xmlns:p="http://schemas.openxmlformats.org/presentationml/2006/main">
+  <p:cSld>
+    <p:spTree>
+      <p:nvGrpSpPr>
+        <p:cNvPr id="1" name=""/>
+        <p:cNvGrpSpPr/>
+        <p:nvPr/>
+      </p:nvGrpSpPr>
+      <p:grpSpPr>
+        <a:xfrm>
+          <a:off x="0" y="0"/>
+          <a:ext cx="0" cy="0"/>
+          <a:chOff x="0" y="0"/>
+          <a:chExt cx="0" cy="0"/>
+        </a:xfrm>
+      </p:grpSpPr>
+      <p:sp>
+        <p:nvSpPr>
+          <p:cNvPr id="2" name="Slide Number Placeholder 1">
+            <a:extLst>
+              <a:ext uri="{FF2B5EF4-FFF2-40B4-BE49-F238E27FC236}">
+                <a16:creationId xmlns:a16="http://schemas.microsoft.com/office/drawing/2014/main" id="{159CE9FC-1BAC-3AC6-42B3-0FDE54699F51}"/>
+              </a:ext>
+            </a:extLst>
+          </p:cNvPr>
+          <p:cNvSpPr>
+            <a:spLocks noGrp="1"/>
+          </p:cNvSpPr>
+          <p:nvPr>
+            <p:ph type="sldNum" sz="quarter" idx="12"/>
+          </p:nvPr>
+        </p:nvSpPr>
+        <p:spPr/>
+        <p:txBody>
+          <a:bodyPr/>
+          <a:lstStyle/>
+          <a:p>
+            <a:fld id="{B6F15528-21DE-4FAA-801E-634DDDAF4B2B}" type="slidenum">
+              <a:rPr lang="en-US" smtClean="0"/>
+              <a:pPr/>
+              <a:t>24</a:t>
             </a:fld>
             <a:endParaRPr lang="en-US"/>
           </a:p>
@@ -8169,27 +8411,15 @@
               <a:buNone/>
             </a:pPr>
             <a:r>
-              <a:rPr lang="en-AU" dirty="0">
-                <a:highlight>
-                  <a:srgbClr val="FFFF00"/>
-                </a:highlight>
-              </a:rPr>
+              <a:rPr lang="en-AU" dirty="0"/>
               <a:t>5. </a:t>
             </a:r>
             <a:r>
-              <a:rPr lang="en-AU" b="1" dirty="0">
-                <a:highlight>
-                  <a:srgbClr val="FFFF00"/>
-                </a:highlight>
-              </a:rPr>
+              <a:rPr lang="en-AU" b="1" dirty="0"/>
               <a:t>Interacting with Blossom and Ultrasonic sensor </a:t>
             </a:r>
             <a:r>
-              <a:rPr lang="en-AU" dirty="0">
-                <a:highlight>
-                  <a:srgbClr val="FFFF00"/>
-                </a:highlight>
-              </a:rPr>
+              <a:rPr lang="en-AU" dirty="0"/>
               <a:t>- 40 min</a:t>
             </a:r>
           </a:p>

</xml_diff>